<commit_message>
Discurso en primera persona en las notas de las 56 diapositivas; guion.md para leer y ensayar
Las notas de contexto anteriores (fuentes y matices) quedan en presentacion/notas_contexto.md.

Co-Authored-By: Claude Opus 5.5 <noreply@anthropic.com>
Claude-Session: https://claude.ai/code/session_018kSg57fGNu2QzjsxgvixHj
</commit_message>
<xml_diff>
--- a/presentacion/IA-para-la-investigacion_sin-videos.pptx
+++ b/presentacion/IA-para-la-investigacion_sin-videos.pptx
@@ -786,7 +786,7 @@
           <a:lstStyle/>
           <a:p>
             <a:r>
-              <a:t>Portada. Déjala en pantalla mientras la gente se sienta.</a:t>
+              <a:t>Buenos días. Gracias a la Clínica Somer por la invitación. Soy Juan David Martínez, profesor de EAFIT, y trabajo en aprendizaje automático aplicado, sobre todo en análisis de marcha y exoesqueletos. Hoy quiero contarles qué cambió en la inteligencia artificial en los últimos años y cómo se está usando ya como herramienta de investigación. Y les voy a dejar una pregunta que nos va a acompañar toda la charla: ¿quién decide qué cuenta como mejor?</a:t>
             </a:r>
           </a:p>
         </p:txBody>
@@ -844,7 +844,7 @@
           <a:lstStyle/>
           <a:p>
             <a:r>
-              <a:t>Imaginen un solo parámetro. Si lo subo un poquito, ¿la pérdida sube o baja? Esa pendiente es el gradiente, y se calcula para todos los parámetros a la vez con retropropagación. El paso: mover cada número un poco en contra de su pendiente. El tamaño del paso es la tasa de aprendizaje.</a:t>
+              <a:t>¿Y cómo sabe qué números cambiar? Imaginen un solo número, un solo parámetro. Si lo subo un poquito, ¿la pérdida sube o baja? Esa pendiente es el gradiente. La regla es muy sencilla: mover el número un poco en contra de la pendiente, y repetir. Con un método que se llama retropropagación, esa pendiente se calcula para todos los números del modelo a la vez.</a:t>
             </a:r>
           </a:p>
         </p:txBody>
@@ -902,7 +902,7 @@
           <a:lstStyle/>
           <a:p>
             <a:r>
-              <a:t>Con dos parámetros ya se puede dibujar: un paisaje, y el modelo baja paso a paso. Con miles de millones no se puede dibujar, pero la regla es la misma. Esta es la forma de todo lo que sigue: proponer, juzgar con la pérdida, actualizar.</a:t>
+              <a:t>Con dos parámetros ya podemos dibujarlo: es un paisaje, y el entrenamiento es bajar por él, paso a paso. A la derecha ven cómo cae la pérdida. Con 405 mil millones de parámetros no lo podemos dibujar, pero la regla es exactamente la misma. Y fíjense que ya aparece la forma de toda la charla: proponer, juzgar con la pérdida y actualizar.</a:t>
             </a:r>
           </a:p>
         </p:txBody>
@@ -960,7 +960,7 @@
           <a:lstStyle/>
           <a:p>
             <a:r>
-              <a:t>Para dar escala: 15 billones de tokens son del orden de toda la web de buena calidad que se pudo filtrar. Ese es el preentrenamiento: la etapa que más cuesta y la que pone casi todo el conocimiento. Llama es de los pocos modelos de frontera que publica estas cifras.</a:t>
+              <a:t>Para que se hagan una idea de la escala: Llama 3.1 tiene 405 mil millones de parámetros, y se entrenó con 15.6 billones de tokens de texto. Eso se acerca a toda la web de buena calidad que se pudo recolectar y filtrar. A esta etapa se le llama preentrenamiento. Es la más costosa y es la que le da al modelo casi todo lo que sabe.</a:t>
             </a:r>
           </a:p>
         </p:txBody>
@@ -1018,7 +1018,7 @@
           <a:lstStyle/>
           <a:p>
             <a:r>
-              <a:t>El embedding de «pesada» es el mismo en cualquier frase. Para entender, cada token necesita mirar a los demás y decidir cuáles importan. Ese mecanismo es la atención, la pieza central del transformer.</a:t>
+              <a:t>Pero hay un problema. Lean estas dos frases. «El robot no levantó la caja porque estaba muy pesada»: pesada es la caja. «…porque estaba muy cansado»: cansado es el robot. Una palabra sola no basta; su sentido depende de las demás. El modelo necesita una forma de que cada palabra mire a las otras y decida cuáles le importan. Esa forma se llama atención.</a:t>
             </a:r>
           </a:p>
         </p:txBody>
@@ -1076,7 +1076,7 @@
           <a:lstStyle/>
           <a:p>
             <a:r>
-              <a:t>Cada token hace una consulta (Q) y la compara con la clave (K) de los demás; el softmax vuelve esos puntajes pesos que suman 1, y con ellos mezcla los valores (V). Q, K y V tienen colores fijos que no se usan en otra parte. Los pesos son ilustrativos hasta correr datos_atencion.py con BETO.</a:t>
+              <a:t>Así funciona la atención. La palabra «pesada» hace una pregunta, y la compara con cada una de las otras palabras. El resultado son pesos que suman uno: cuánto mira a cada palabra. Aquí el peso mayor cae en «caja», que es justamente a lo que se refiere. Con esos pesos, «pesada» mezcla la información de las otras palabras. Esa es la fórmula de abajo, y es la pieza central de todos los modelos actuales.</a:t>
             </a:r>
           </a:p>
         </p:txBody>
@@ -1134,7 +1134,7 @@
           <a:lstStyle/>
           <a:p>
             <a:r>
-              <a:t>Un bloque tiene dos pasos. Atención: cada token toma información de los otros. MLP: cada token, por separado, transforma lo que reunió; ahí se guarda buena parte del conocimiento. Las flechas que rodean cada paso son conexiones residuales: el bloque suma una corrección, no reescribe todo.</a:t>
+              <a:t>Un bloque del transformer tiene dos pasos. Primero, la atención: los tokens intercambian información entre ellos. Después, una red neuronal que trabaja cada token por separado; ahí se guarda buena parte de lo que el modelo sabe. Las flechas de arriba son conexiones residuales: cada paso suma una corrección a lo que ya había, no lo reescribe todo.</a:t>
             </a:r>
           </a:p>
         </p:txBody>
@@ -1192,7 +1192,7 @@
           <a:lstStyle/>
           <a:p>
             <a:r>
-              <a:t>Las capas de abajo capturan forma; las de arriba, significado y razonamiento. Al final, el vector del último token se compara con todo el vocabulario y sale la distribución de la diapositiva 5. Eso es todo el programa de la diapositiva 3.</a:t>
+              <a:t>Y esos bloques se apilan. Llama 3.1 tiene 126. Los vectores suben por la pila, bloque tras bloque, y se van refinando. Al final, el vector del último token se convierte en las probabilidades del siguiente token, las mismas que vimos hace un momento. Ese es, completo, el programa del que les hablé al principio.</a:t>
             </a:r>
           </a:p>
         </p:txBody>
@@ -1250,7 +1250,7 @@
           <a:lstStyle/>
           <a:p>
             <a:r>
-              <a:t>La atención solo mira lo que está en la ventana. Lo que no está ahí, el modelo no lo sabe, salvo lo que quedó en sus parámetros con fecha de corte. Por eso lo que le pones (tus papers, tus datos, tus reglas) importa tanto como el modelo. Esta idea vuelve en la Parte 3.</a:t>
+              <a:t>Una consecuencia muy práctica: el modelo solo puede mirar lo que está en su ventana de contexto. Es su memoria de trabajo. En Claude son unos 200 mil tokens: ahí caben sus instrucciones, sus papers, la conversación. Lo que no está en la ventana no existe para el modelo, salvo lo que aprendió en el entrenamiento, que tiene fecha de corte. Por eso lo que ustedes le dan, sus documentos y sus reglas, importa tanto como el modelo mismo.</a:t>
             </a:r>
           </a:p>
         </p:txBody>
@@ -1308,7 +1308,7 @@
           <a:lstStyle/>
           <a:p>
             <a:r>
-              <a:t>Cada curva es un tamaño de modelo; la envolvente baja como una ley de potencia. Por eso los laboratorios apuestan miles de millones: el resultado se puede predecir antes de entrenar. Chinchilla mostró que conviene crecer parámetros y datos a la par, unos 20 tokens por parámetro.</a:t>
+              <a:t>¿Y por qué las empresas invierten miles de millones en entrenar modelos más grandes? Por esto: las leyes de escala. La pérdida baja de forma predecible cuando aumentan los parámetros y los datos. Cada curva es un tamaño de modelo, y la línea blanca es el mejor resultado posible para cada presupuesto. El trabajo de Chinchilla mostró que conviene crecer modelo y datos a la par: unos veinte tokens por parámetro. Se puede predecir el resultado antes de entrenar.</a:t>
             </a:r>
           </a:p>
         </p:txBody>
@@ -1366,7 +1366,7 @@
           <a:lstStyle/>
           <a:p>
             <a:r>
-              <a:t>El modelo base aprendió a continuar documentos: si el texto parece un examen, sigue con más preguntas. Sabe mucho, pero no tiene el rol de asistente. Las dos etapas que siguen cambian el comportamiento, no el conocimiento.</a:t>
+              <a:t>Ahora, un modelo recién preentrenado no es un asistente. Solo sabe continuar textos. Si le pregunto «¿cuáles son las fases de la marcha?», puede seguir con más preguntas, como si fuera un examen. Sabe mucho, pero no sabe que tiene que responder. Para convertirlo en asistente hacen falta dos etapas más, y en cada una cambia el juez.</a:t>
             </a:r>
           </a:p>
         </p:txBody>
@@ -1424,7 +1424,7 @@
           <a:lstStyle/>
           <a:p>
             <a:r>
-              <a:t>Pregunta: ¿quién corrió más experimentos anoche, ustedes o este script? Aquí se fija el código de color de toda la charla: ámbar es lo que el juez conservó, gris lo que descartó. El video usa datos ilustrativos (lo dice en la esquina); con tu results.tsv real se regenera.</a:t>
+              <a:t>Empiezo con esto. Lo que ven es el registro de un agente de IA que corrió toda una noche. Cada línea es un experimento: el agente cambia algo en el código de un modelo, lo entrena cinco minutos y mira si mejoró. Si mejoró, lo conserva; esos van en ámbar. Si no, lo descarta; esos van en gris. Setenta y dos experimentos, ocho horas, ninguna persona despierta. Les pregunto: ¿quién de ustedes corrió setenta y dos experimentos anoche? Fíjense en el color ámbar, porque va a aparecer toda la charla: es lo que el juez decidió conservar.</a:t>
             </a:r>
           </a:p>
         </p:txBody>
@@ -1482,7 +1482,7 @@
           <a:lstStyle/>
           <a:p>
             <a:r>
-              <a:t>SFT por sus siglas en inglés. La pérdida es la misma de antes, pero sobre textos elegidos: conversaciones. LIMA mostró que con solo 1,000 ejemplos bien escogidos ya se obtiene mucho del comportamiento de asistente.</a:t>
+              <a:t>La primera es el ajuste fino. Se le muestran miles de conversaciones modelo, escritas o revisadas por personas: una pregunta y la respuesta ideal. Con eso aprende el formato y el rol: responder, seguir instrucciones, decir cuando no sabe. No aprende conocimiento nuevo; eso ya venía del preentrenamiento. El juez ya no es el texto de internet: son ejemplos humanos.</a:t>
             </a:r>
           </a:p>
         </p:txBody>
@@ -1540,7 +1540,7 @@
           <a:lstStyle/>
           <a:p>
             <a:r>
-              <a:t>Aprendizaje por refuerzo con retroalimentación humana. El juez ahora son las preferencias de personas, resumidas en un modelo de recompensa. Riesgo conocido: el modelo aprende a sonar convincente y a dar la razón. DPO hace lo mismo sin el modelo de recompensa aparte.</a:t>
+              <a:t>La segunda se llama RLHF, aprendizaje por refuerzo con retroalimentación humana. El modelo escribe dos respuestas, una persona elige la mejor, un segundo modelo aprende a predecir esas elecciones, y el modelo original se ajusta para ganar. Ahora el juez son las preferencias de las personas. Ojo con esto: premia lo que nos parece mejor, no necesariamente lo que es verdad. Por eso a veces los modelos suenan muy convincentes y se equivocan.</a:t>
             </a:r>
           </a:p>
         </p:txBody>
@@ -1598,7 +1598,7 @@
           <a:lstStyle/>
           <a:p>
             <a:r>
-              <a:t>Aprendizaje por refuerzo con recompensas verificables: matemáticas, tests que pasan. Nadie le muestra el procedimiento: solo un verificador que dice sí o no. Así salieron los modelos de razonamiento con cadenas de pensamiento largas. Idea clave: los modelos son más fuertes donde la respuesta se puede verificar.</a:t>
+              <a:t>La novedad de los últimos dos años es otro juez: un verificador. Le doy un problema con respuesta comprobable, por ejemplo 17 por 24. El modelo intenta ocho veces, un verificador marca cuáles son correctas, y el modelo se refuerza hacia las correctas. Nadie le enseña a multiplicar: solo hay un juez que dice sí o no. Así se entrenaron los modelos que razonan paso a paso. La lección para nosotros: los modelos son más fuertes donde la respuesta se puede verificar.</a:t>
             </a:r>
           </a:p>
         </p:txBody>
@@ -1656,7 +1656,7 @@
           <a:lstStyle/>
           <a:p>
             <a:r>
-              <a:t>Dos ideas. Primero, cómputo en inferencia: dejar pensar al modelo, o muestrear varias respuestas y votar. Segundo, ¿qué pasa cuando no hay respuesta verificable? DR Tulu usa rúbricas que se refinan a partir de las respuestas y de la evidencia recuperada. Lo retomamos en deep research.</a:t>
+              <a:t>Dos ideas más sobre esto. Primero, dejar que el modelo piense más tiempo, o que intente varias veces, mejora la precisión, pero solo si ya es bueno en esa tarea. Segundo, ¿qué pasa cuando no hay una respuesta única, como en un reporte de literatura? Un trabajo de este año, DR Tulu, usa rúbricas que se van refinando durante el entrenamiento. Es decir, el juez ya no solo evalúa: también entrena.</a:t>
             </a:r>
           </a:p>
         </p:txBody>
@@ -1714,7 +1714,7 @@
           <a:lstStyle/>
           <a:p>
             <a:r>
-              <a:t>La imagen se corta en parches, cada parche se proyecta a un vector, y entra a la misma secuencia que el texto. Audio y video igual, por fragmentos. Idea clave: tus videos y datos de sensores ya son entradas posibles, pero siguen necesitando una verdad de referencia.</a:t>
+              <a:t>Cierro esta parte con algo que les interesa directamente: las imágenes. Una imagen se corta en cuadritos, y cada cuadrito se vuelve un token, igual que una palabra. Esta imagen de marcha se convierte en 196 tokens, que entran junto con el texto al mismo modelo. Con el audio y el video pasa lo mismo. Es decir, sus videos clínicos y sus datos de sensores ya pueden ser entradas de un modelo general. Pero siguen necesitando una verdad de referencia contra la cual comparar.</a:t>
             </a:r>
           </a:p>
         </p:txBody>
@@ -1772,7 +1772,7 @@
           <a:lstStyle/>
           <a:p>
             <a:r>
-              <a:t>Gancho de la Parte 2: «La mayoría de ustedes está en el ciclo del chat. La frontera está en este otro ciclo.» Por disciplina: 39% de los economistas y 25% de los politólogos usan agentes, frente a cifras de un dígito en salud pública, educación y comunicación. Por etapa: algo más de un cuarto de doctorandos y posdocs. Sé honesto con la muestra: se reclutó ofreciendo cuentas de Claude Max, así que sobrerrepresenta a interesados en IA, y Anthropic es parte interesada.</a:t>
+              <a:t>Pasemos a los agentes. Una encuesta de este año a más de mil científicos sociales encontró que el 81 por ciento ha probado chatbots para investigar, pero solo el 20 por ciento usa agentes con frecuencia. Con una advertencia: la muestra no es representativa; se reclutó ofreciendo cuentas de Claude. Aun así, la idea se sostiene: casi todos estamos en el chat, y la frontera está en los agentes.</a:t>
             </a:r>
           </a:p>
         </p:txBody>
@@ -1830,7 +1830,7 @@
           <a:lstStyle/>
           <a:p>
             <a:r>
-              <a:t>El modelo puede ser exactamente el mismo. Lo que cambia es el programa que lo envuelve: en el chat, tú eres quien ejecuta y trae los resultados de vuelta; en el agente, el programa lo hace y el modelo decide el siguiente paso.</a:t>
+              <a:t>¿Qué cambió entre un chat y un agente? En el chat, el modelo responde una vez. Si le pido un script, me lo da; yo lo corro, me sale un error, se lo pego, y así. Yo soy el que actúa. Un agente recibe una meta. Busca, abre archivos, corre código, mira el resultado y decide el siguiente paso él mismo, hasta terminar. Lo importante: el modelo puede ser exactamente el mismo. Lo que cambia es el programa que lo rodea.</a:t>
             </a:r>
           </a:p>
         </p:txBody>
@@ -1888,7 +1888,7 @@
           <a:lstStyle/>
           <a:p>
             <a:r>
-              <a:t>Estas tres piezas convierten un predictor de texto en algo que trabaja. Cada una trae su riesgo: herramientas que hacen daño, estado que se ensucia, y errores que se acumulan a lo largo de muchos pasos.</a:t>
+              <a:t>Ese programa le agrega tres cosas. Herramientas: puede buscar, leer archivos, ejecutar código. Estado: guarda un plan y notas que sobreviven entre pasos. Y muchos pasos: decenas o cientos de acciones sin que uno intervenga. Cada una trae su riesgo, y lo vamos a ver. Pero quédense con esto: lo nuevo no está en el modelo, está alrededor. A eso le vamos a llamar el harness.</a:t>
             </a:r>
           </a:p>
         </p:txBody>
@@ -1946,7 +1946,7 @@
           <a:lstStyle/>
           <a:p>
             <a:r>
-              <a:t>Desmitifica la palabra «herramienta». El modelo solo genera texto; cuando genera una llamada con el formato acordado, el programa la detecta, la ejecuta y pega el resultado en el contexto. El modelo nunca toca internet: lee lo que el programa le devuelve.</a:t>
+              <a:t>Les quiero quitar el misterio a la palabra «herramienta». Una herramienta es texto. Lo azul lo escribe el modelo: piensa, y luego escribe una orden de búsqueda con un formato acordado. El programa detecta esa orden, ejecuta la búsqueda de verdad y pega el resultado; eso es lo gris. Luego el modelo lee el resultado y decide: este estudio no tiene pacientes, lo descarto; abro el otro. El modelo nunca toca internet: solo lee lo que el programa le devuelve.</a:t>
             </a:r>
           </a:p>
         </p:txBody>
@@ -2004,7 +2004,7 @@
           <a:lstStyle/>
           <a:p>
             <a:r>
-              <a:t>El patrón ReAct: un modelo de lenguaje en un ciclo con herramientas. El resultado de cada herramienta vuelve como retroalimentación: el error de un script, el contenido de un archivo, una búsqueda vacía. Ese es el juez de esta parte.</a:t>
+              <a:t>Eso, en ciclo, es un agente: observar, pensar, actuar y ver el resultado. Y aquí el juez son las herramientas. Si el código falla, el error vuelve al modelo. Si la búsqueda no encuentra nada, eso también vuelve. Cada resultado es el juez del paso siguiente.</a:t>
             </a:r>
           </a:p>
         </p:txBody>
@@ -2062,7 +2062,7 @@
           <a:lstStyle/>
           <a:p>
             <a:r>
-              <a:t>Diapositiva de la tesis. Todo es el mismo ciclo: algo propone, algo juzga, algo actualiza. Lee la columna del juez de arriba abajo: pasa de los datos a los humanos, a los verificadores, a las herramientas, a tus reglas y al final a tu métrica. Cada diapositiva de ciclo lleva una etiqueta «Juez» arriba a la derecha.</a:t>
+              <a:t>Esta es la idea central de hoy. Todo lo que vamos a ver tiene la misma forma: algo propone, algo juzga y algo se actualiza. Lo que cambia de una etapa a otra es quién hace de juez. Al entrenar un modelo, el juez es el texto mismo. Al alinearlo, son las preferencias de personas. Para razonar, un verificador. En los agentes, las herramientas. Y al final, el juez es tu métrica. Mi tesis es esta: cuando el juez pasa de los datos a ustedes, el trabajo del investigador pasa de producir resultados a juzgarlos.</a:t>
             </a:r>
           </a:p>
         </p:txBody>
@@ -2120,7 +2120,7 @@
           <a:lstStyle/>
           <a:p>
             <a:r>
-              <a:t>Al principio los agentes eran puro prompt sobre un chat. Hoy los modelos se entrenan sobre trayectorias de agente, con las etapas de la Parte 1: preentrenamiento, ajuste fino y refuerzo. METR mide la duración, en tiempo humano, de las tareas que un modelo completa con 50% de éxito; entre 2019 y 2025 se duplicó cada siete meses aproximadamente.</a:t>
+              <a:t>¿Por qué esto funciona ahora y no hace tres años? Porque los modelos se empezaron a entrenar para usar herramientas. En 2022 se le pedía al modelo, con instrucciones, que alternara pensar y actuar. En 2023 aprendieron el formato de las llamadas. Desde 2024 se entrenan con refuerzo sobre tareas de agente completas. Un grupo que se llama METR mide la duración de las tareas que logran terminar, y esa duración se ha duplicado más o menos cada siete meses.</a:t>
             </a:r>
           </a:p>
         </p:txBody>
@@ -2178,7 +2178,7 @@
           <a:lstStyle/>
           <a:p>
             <a:r>
-              <a:t>El ejemplo es de la clase de Akari Asai. La segunda pregunta no se responde con un dato: hay que separar benchmarks de comparaciones directas con expertos, y la respuesta honesta es matizada: prometedor en las tareas probadas, paridad con expertos aún no demostrada.</a:t>
+              <a:t>Uno de los usos más útiles para nosotros es el deep research: investigación profunda. Hay preguntas que se responden con una búsqueda, como la oficina de una profesora. Y hay otras, como «¿pueden los agentes sintetizar literatura tan bien como los expertos?», que exigen planear, buscar, leer, darse cuenta de que falta algo, buscar otra vez y escribir con citas. Este ejemplo es de la clase de Akari Asai en Carnegie Mellon, que recomiendo mucho.</a:t>
             </a:r>
           </a:p>
         </p:txBody>
@@ -2236,7 +2236,7 @@
           <a:lstStyle/>
           <a:p>
             <a:r>
-              <a:t>Patrón orquestador-trabajadores: el líder guarda su plan en memoria y lanza subagentes que buscan en paralelo, cada uno con su propia ventana de contexto. El «¿basta?» es el juez en tiempo de ejecución. Al final, un agente de citas asocia cada afirmación con su fuente. Ojo: es una evaluación interna del propio fabricante.</a:t>
+              <a:t>Así funciona por dentro el sistema de deep research de Anthropic. Un agente líder recibe la pregunta, hace un plan y reparte el trabajo entre varios subagentes que buscan en paralelo, cada uno con su propia ventana de contexto. El líder decide si con eso basta; ese rombo ámbar es el juez. Al final, otro agente revisa que cada afirmación tenga su fuente. En su evaluación interna, esto supera en 90 por ciento a un solo agente, pero gasta unas quince veces más tokens que una conversación normal.</a:t>
             </a:r>
           </a:p>
         </p:txBody>
@@ -2294,7 +2294,7 @@
           <a:lstStyle/>
           <a:p>
             <a:r>
-              <a:t>1,266 preguntas escritas por personas, cada una armada con pistas para que la respuesta sea fácil de verificar y difícil de encontrar. Buscar en la web ayuda poco a un chat; un agente entrenado para buscar llega a la mitad. Pero un benchmark de respuesta corta no mide un reporte: para eso están las rúbricas, en la Parte 5.</a:t>
+              <a:t>¿Y cómo sabemos si funcionan? Con benchmarks como BrowseComp: preguntas escritas para obligar a buscar mucho. Un modelo de chat responde menos del dos por ciento. Un modelo que razona, cerca del diez. El agente de deep research llega a la mitad. Pero ojo: estas son preguntas con respuesta corta. Un reporte de literatura es otra cosa, y para eso hacen falta otros jueces, que veremos al final.</a:t>
             </a:r>
           </a:p>
         </p:txBody>
@@ -2352,7 +2352,7 @@
           <a:lstStyle/>
           <a:p>
             <a:r>
-              <a:t>Es la Parte 1 otra vez: preentrenar, ajustar con ejemplos y reforzar con un juez. Lo único nuevo es que el texto incluye llamadas a herramientas y sus resultados. Así el agente no solo «sabe» usar herramientas por prompt: lo aprendió.</a:t>
+              <a:t>Y se entrenan con las mismas tres etapas que vimos en la primera parte, ahora con herramientas. Preentrenamiento con trayectorias de agentes. Ajuste fino imitando a un modelo maestro, pero solo las trayectorias que llegaron a la respuesta correcta. Y refuerzo, con un juez: la respuesta correcta, o rúbricas cuando se trata de reportes. Es la primera parte de la charla otra vez.</a:t>
             </a:r>
           </a:p>
         </p:txBody>
@@ -2410,7 +2410,7 @@
           <a:lstStyle/>
           <a:p>
             <a:r>
-              <a:t>Además de la búsqueda web, muchos agentes usan búsqueda por embeddings sobre una colección propia: tus PDFs, por ejemplo. El problema que señala Asai: el buscador normalmente solo ve la última consulta, no lo que el agente está pensando.</a:t>
+              <a:t>Y para buscar en sus propios documentos, los agentes usan los embeddings que vimos al principio. Cada documento se convierte en un vector; la pregunta también; y se devuelven los más cercanos. Un trabajo reciente, AgentIR, mostró que si al buscador se le pasa también el razonamiento del agente, y no solo la pregunta, encuentra más con menos búsquedas.</a:t>
             </a:r>
           </a:p>
         </p:txBody>
@@ -2468,7 +2468,7 @@
           <a:lstStyle/>
           <a:p>
             <a:r>
-              <a:t>Este es el momento de juntar piezas. El modelo es la Parte 1; la ventana de contexto, la diapositiva 16; las herramientas, la Parte 2; la verificación, los jueces de toda la charla. Harness es el nombre de todo lo que rodea al modelo. Ejemplo extremo: el equipo de OpenAI que escribió cerca de un millón de líneas sin escribir ninguna a mano; su trabajo fue diseñar el entorno.</a:t>
+              <a:t>Llegamos a la tercera parte, y aquí junto todo. Esto es el harness: todo lo que rodea al modelo. El modelo, que vimos en la primera parte. El contexto, que es la ventana de contexto. Las herramientas, de la segunda parte. Las instrucciones, los skills y los permisos, que veremos ahora. Y la verificación, en ámbar, que son los jueces de toda la charla. El mismo modelo da resultados muy distintos según el harness que lo rodea.</a:t>
             </a:r>
           </a:p>
         </p:txBody>
@@ -2526,7 +2526,7 @@
           <a:lstStyle/>
           <a:p>
             <a:r>
-              <a:t>La pieza más barata del harness. Claude Code lee CLAUDE.md; otros agentes usan AGENTS.md, que hoy es casi un estándar. Pon ahí lo que le dirías a un estudiante nuevo del laboratorio el primer día.</a:t>
+              <a:t>La pieza más sencilla son las instrucciones. En Claude Code se escribe un archivo, CLAUDE.md, que el agente lee al empezar cada sesión. Es lo que uno le diría a un estudiante nuevo del laboratorio el primer día: dónde están los datos, qué no se toca, que toda cifra lleva su fuente, que nunca invente una cita. Debe ser corto, un mapa y no un manual. Es su criterio, escrito una sola vez.</a:t>
             </a:r>
           </a:p>
         </p:txBody>
@@ -2584,7 +2584,7 @@
           <a:lstStyle/>
           <a:p>
             <a:r>
-              <a:t>Vuelve a la diapositiva 16, la de la ventana de contexto. Un agente que trabaja horas llena 200,000 tokens rápido: cada resultado de herramienta entra ahí. Por eso el sistema de deep research usa subagentes: cada uno busca con una ventana limpia y le devuelve al líder solo un resumen.</a:t>
+              <a:t>La segunda pieza es el contexto: lo que el agente tiene a la vista. Siempre entran las instrucciones; al trabajar entran los archivos que abre y los resultados de cada herramienta. Y se llena rápido. Por eso los agentes resumen, o reparten el trabajo en subagentes, como en el sistema de deep research. Y una advertencia: más contexto no siempre es mejor; lo que no sirve distrae.</a:t>
             </a:r>
           </a:p>
         </p:txBody>
@@ -2642,7 +2642,7 @@
           <a:lstStyle/>
           <a:p>
             <a:r>
-              <a:t>Con datos clínicos, esta es la diapositiva más importante de la parte. Lo que no está en allow, el agente lo pregunta; lo que está en deny, no lo puede hacer. MCP es un protocolo abierto para conectar herramientas nuevas sin programar el agente.</a:t>
+              <a:t>La tercera pieza, y para una clínica quizás la más importante: los permisos. En un archivo de configuración se escribe qué puede hacer el agente sin preguntar, por ejemplo buscar o leer, y qué no puede hacer nunca, por ejemplo borrar archivos o abrir la carpeta de datos de pacientes. Las herramientas nuevas se conectan con un estándar abierto que se llama MCP: Zotero, una base de datos, el correo.</a:t>
             </a:r>
           </a:p>
         </p:txBody>
@@ -2700,7 +2700,7 @@
           <a:lstStyle/>
           <a:p>
             <a:r>
-              <a:t>El encuadre de Karpathy: un modelo abierto es un archivo de parámetros y un programa corto que lo corre. Lo que sigue en esta parte responde dos preguntas: qué hace ese programa con el texto, y de dónde salen los números.</a:t>
+              <a:t>Empecemos por lo básico. ¿Qué es un modelo de lenguaje? Literalmente, dos archivos. Uno tiene números, muchísimos: Llama 3.1, un modelo abierto de Meta, tiene 405 mil millones. El otro es un programa corto que multiplica esos números con el texto que le damos. Nadie escribió esos números a mano. Salieron de entrenar el modelo con texto. Las próximas diapositivas responden dos preguntas: qué hace ese programa con el texto, y cómo se aprenden esos números.</a:t>
             </a:r>
           </a:p>
         </p:txBody>
@@ -2758,7 +2758,7 @@
           <a:lstStyle/>
           <a:p>
             <a:r>
-              <a:t>Un skill empaqueta algo que haces seguido: la forma en que tu grupo revisa una figura, prepara un reporte o limpia datos. El ejemplo de las próximas diapositivas es revisar-figura.</a:t>
+              <a:t>La cuarta pieza son los skills. Un skill es una carpeta con instrucciones para una tarea que ustedes repiten: por ejemplo, revisar una figura antes de enviar un artículo. Tiene un archivo con los pasos, puede tener referencias y scripts. Es texto: se lee, se edita y se versiona como cualquier código. Y desde el año pasado es un estándar abierto, así que no depende de una sola herramienta.</a:t>
             </a:r>
           </a:p>
         </p:txBody>
@@ -2816,7 +2816,7 @@
           <a:lstStyle/>
           <a:p>
             <a:r>
-              <a:t>Conecta con la diapositiva anterior de contexto: los skills son la forma de tener mucho conocimiento disponible sin pagarlo en tokens hasta que se usa.</a:t>
+              <a:t>Lo interesante de los skills es cómo se cargan. Al iniciar, el agente solo lee el nombre y la descripción de cada uno. Si la tarea coincide, abre las instrucciones completas. Si hace falta, abre las referencias. Y los scripts corren sin ocupar contexto. Por eso se pueden tener decenas de skills instalados sin llenar la ventana.</a:t>
             </a:r>
           </a:p>
         </p:txBody>
@@ -2874,7 +2874,7 @@
           <a:lstStyle/>
           <a:p>
             <a:r>
-              <a:t>Los dos campos obligatorios son name y description. El error más común es una descripción vaga: el agente decide si abrir el skill solo con ella. El cuerpo puede apuntar a otros archivos para no crecer demasiado.</a:t>
+              <a:t>Así se ve uno por dentro. Arriba, dos campos: el nombre y la descripción. La descripción es lo más importante, porque es lo único que el agente ve al principio: si es vaga, el skill nunca se activa. Abajo van los pasos, escritos como se los explicaría a un estudiante.</a:t>
             </a:r>
           </a:p>
         </p:txBody>
@@ -2932,7 +2932,7 @@
           <a:lstStyle/>
           <a:p>
             <a:r>
-              <a:t>Demo en vivo (con respaldo grabado): pídele al agente que cree el skill revisar-figura a partir de estos cinco pasos, luego dale una figura real y muestra que el skill se activa solo, por su descripción. Puntos clave de Anthropic: empieza por ver dónde falla el agente; cuida la descripción, porque decide cuándo se activa; divide un SKILL.md largo en archivos; e itera con el propio agente, pidiéndole que guarde lo que funcionó y los errores comunes. Un skill es texto plano: lo puedes leer, editar y versionar en git como cualquier código.</a:t>
+              <a:t>¿Cómo se crea uno? Elijan algo que ya hicieron tres veces. Escriban los pasos y los errores típicos. Describan cuándo usarlo. Pasen lo mecánico a un script. Y pruébenlo en casos reales. Lo pueden hacer pidiéndoselo al mismo agente: créame un skill con estos pasos. Si hay tiempo, lo muestro en vivo.</a:t>
             </a:r>
           </a:p>
         </p:txBody>
@@ -2990,7 +2990,7 @@
           <a:lstStyle/>
           <a:p>
             <a:r>
-              <a:t>Los tres ejemplos son reales y públicos. El de Bäckman es el mejor punto de partida para cualquier investigador: corre varios revisores en paralelo sobre tu borrador y guarda el reporte en una carpeta reviews/. Sus propias instrucciones advierten que el reporte «no es todo correcto»: el agente produce, tú juzgas. La advertencia de seguridad viene de Anthropic: un skill de una fuente poco confiable puede inducir acciones no deseadas o exfiltrar datos, así que se audita antes de instalarlo, igual que una dependencia de código.</a:t>
+              <a:t>Y no tienen que empezar de cero. Hay skills públicos para investigar. Uno que recomiendo es el de Claes Bäckman para revisar artículos: varios agentes revisores le escriben un reporte de árbitro a su borrador en unos quince minutos. Hay otros para bases de datos biomédicas, como PubMed. Una advertencia: instalen solo de fuentes confiables y léanlos antes, porque un skill le puede ordenar al agente cosas que ustedes no quieren.</a:t>
             </a:r>
           </a:p>
         </p:txBody>
@@ -3048,7 +3048,7 @@
           <a:lstStyle/>
           <a:p>
             <a:r>
-              <a:t>Esta diapositiva conecta la Parte 3 con la tesis. Las cuatro prácticas vienen de los textos de OpenAI y Google: un archivo de instrucciones corto que funciona como mapa; restricciones que se verifican mecánicamente; evaluaciones de comportamiento, que Google describe como tests de integración del harness; y una revisión independiente. Todas son formas de escribir tu criterio de «mejor» para que el agente lo respete sin ti. Ejemplo concreto, el sistema multiagente de la diapositiva 31: Anthropic lo evaluó con un LLM como juez y una rúbrica de cinco criterios (exactitud factual, exactitud de citas, completitud, calidad de fuentes y eficiencia en el uso de herramientas); empezó con unas 20 preguntas, sin esperar una batería grande; y aun así los evaluadores humanos encontraron lo que la rúbrica no veía: los primeros agentes preferían granjas de contenido optimizadas para SEO sobre fuentes autorizadas. El juez automático escala; el juez humano detecta lo que nadie pensó medir. Puente a la Parte 4: en autoresearch, Karpathy no escribe Python; escribe program.md, y la métrica decide.</a:t>
+              <a:t>La última pieza del harness es la evaluación, y para mí es la más importante. Hacer harness engineering es diseñar el juez: un archivo corto de instrucciones, pruebas que el agente no puede saltarse, revisar cómo se comportó, y un revisor independiente, otro agente u otro modelo, que ataque el resultado. Todas son formas de escribir su criterio de «mejor» para que el agente lo respete sin ustedes al lado.</a:t>
             </a:r>
           </a:p>
         </p:txBody>
@@ -3106,7 +3106,7 @@
           <a:lstStyle/>
           <a:p>
             <a:r>
-              <a:t>La versión en miniatura de todo lo que sigue, y la única que pueden correr esta noche. El agente edita un solo archivo, entrena 5 minutos y conserva el cambio solo si mejora la validación. Ojo: es un repositorio, no un paper; los trabajos que siguen son la evidencia publicada.</a:t>
+              <a:t>Cuarta parte: IA que investiga. Vuelvo al ejemplo del principio. Esto es autoresearch, de Andrej Karpathy. El agente cambia una sola cosa del código, entrena cinco minutos, mira la métrica y conserva el cambio solo si mejora. Y otra vez, y otra vez. Aquí el juez es su métrica, y el agente hace todo lo demás. Es un repositorio, no un artículo; lo que sigue es la evidencia publicada.</a:t>
             </a:r>
           </a:p>
         </p:txBody>
@@ -3164,7 +3164,7 @@
           <a:lstStyle/>
           <a:p>
             <a:r>
-              <a:t>Es un harness completo en un archivo de texto: instrucciones, permisos (solo train.py), herramienta (entrenar), memoria (git) y juez (val_bpb). El humano programa en lenguaje natural; el agente, en Python.</a:t>
+              <a:t>Lo que escribe la persona no es código: es un archivo de instrucciones, program.md. La meta, qué puede tocar, cuánto dura cada experimento, qué hacer si mejora y qué hacer si no. Fíjense que es un harness completo en una página: instrucciones, permisos, una herramienta, memoria en git y un juez que el agente no puede cambiar.</a:t>
             </a:r>
           </a:p>
         </p:txBody>
@@ -3222,7 +3222,7 @@
           <a:lstStyle/>
           <a:p>
             <a:r>
-              <a:t>Es deep research más un ciclo de mejora. Cada agente es un prompt distinto sobre el mismo modelo, como los subagentes de la Parte 2. Todas las hipótesis empiezan con Elo 1,200 y suben o bajan según ganen debates.</a:t>
+              <a:t>Google lleva esto a las hipótesis científicas con Co-Scientist. Son seis agentes sobre el mismo modelo: uno propone hipótesis, otro las critica como un revisor, otro las ordena en un torneo, otro combina y mejora las mejores, otro agrupa las parecidas y otro resume las críticas. Es deep research con un ciclo de mejora encima.</a:t>
             </a:r>
           </a:p>
         </p:txBody>
@@ -3280,7 +3280,7 @@
           <a:lstStyle/>
           <a:p>
             <a:r>
-              <a:t>El Elo es el juez interno: barato y rápido, pero es un proxy. El juez que importa viene después: el laboratorio.</a:t>
+              <a:t>El torneo funciona como en el ajedrez. Todas las hipótesis empiezan con el mismo puntaje Elo. Se enfrentan por pares, los agentes debaten cuál es mejor, y el puntaje sube o baja. Pero ese puntaje es un juez interno, barato y rápido. El juez que de verdad importa viene después: el laboratorio.</a:t>
             </a:r>
           </a:p>
         </p:txBody>
@@ -3338,7 +3338,7 @@
           <a:lstStyle/>
           <a:p>
             <a:r>
-              <a:t>Los cortes y los números son reales: salen del tokenizador de Mistral. Las palabras comunes son un token; las técnicas se parten: «tibiofemoral» queda en seis pedazos. Por eso los modelos se equivocan más con vocabulario de nicho y por eso los precios y los límites se cuentan en tokens.</a:t>
+              <a:t>Primero: el modelo no lee palabras, lee tokens. Un token es un pedazo de texto que tiene un número asignado. Esto que ven es un tokenizador real. Las palabras comunes, como «la» o «fase», son un solo token. Pero miren las palabras de nuestro campo: «tibiofemoral» queda partida en seis pedazos; «electromiografía», en cuatro. Eso explica dos cosas: por qué los modelos se equivocan más con vocabulario técnico, y por qué todo, los precios y los límites, se mide en tokens.</a:t>
             </a:r>
           </a:p>
         </p:txBody>
@@ -3396,7 +3396,7 @@
           <a:lstStyle/>
           <a:p>
             <a:r>
-              <a:t>Tres áreas, tres tipos de evidencia. Lo que los autores reconocen: validación preliminar, no in vivo. Para un público clínico vale subrayarlo: es el inicio del ciclo de validación, no el final.</a:t>
+              <a:t>Y lo llevaron al laboratorio. En leucemia mieloide aguda, un fármaco propuesto mostró una ventana de dieciocho veces entre células tumorales y células control. En fibrosis hepática, dos de tres fármacos propuestos funcionaron en organoides humanos. Pero para un público clínico hay que decirlo claro: esto es validación preliminar, en células y organoides, no en pacientes. Es el comienzo del ciclo, no el final.</a:t>
             </a:r>
           </a:p>
         </p:txBody>
@@ -3454,7 +3454,7 @@
           <a:lstStyle/>
           <a:p>
             <a:r>
-              <a:t>La misma idea: un LLM propone cambios de código y un puntaje automático decide qué se queda. ERA: en integración de datos single-cell, 40 de 87 métodos generados superan el leaderboard publicado. AlphaEvolve: multiplicó matrices complejas 4×4 con 48 multiplicaciones escalares. Ambos solo funcionan donde hay un evaluador automático.</a:t>
+              <a:t>Otro par de sistemas de Google, ERA y AlphaEvolve, hacen lo mismo con código. Un modelo propone cambios a un programa, un evaluador automático los califica, y se conservan los mejores. ERA generó métodos de integración de datos de célula única, y 40 de 87 superan a todos los publicados. AlphaEvolve encontró una forma de multiplicar matrices de cuatro por cuatro con 48 multiplicaciones. Ambos funcionan solo porque existe un evaluador automático.</a:t>
             </a:r>
           </a:p>
         </p:txBody>
@@ -3512,7 +3512,7 @@
           <a:lstStyle/>
           <a:p>
             <a:r>
-              <a:t>Tres sistemas que van de la idea al paper, y un número de cada uno. The AI Scientist (Sakana, Nature 2026): un paper sin edición obtuvo 6, 7 y 6 en un workshop de ICLR 2025, por encima del 55% de los papers humanos; los autores lo retiraron antes de publicarse, y reconocen citas inexactas e ideas ingenuas. Kosmos (Edison): corridas de hasta 12 horas que leen ~1,500 papers y ejecutan ~42,000 líneas de código; científicos independientes juzgaron correctas el 79.4% de sus afirmaciones. Project APE (Zurich): ~1,000 papers de evaluación de políticas en cuatro meses; un juez automático prefiere el paper humano el 88.1% de las veces y su verificador estima que todos tienen errores. Si preguntan por síntesis de literatura en general: OpenScholar (Asai et al., Nature 2026) responde preguntas científicas buscando en la literatura y citando sus fuentes; en una evaluación con 108 pares, los expertos prefirieron sus respuestas sobre las escritas por expertos el 70% de las veces. Mensaje: producir ya no es el cuello de botella; juzgar sí.</a:t>
+              <a:t>Y ya hay sistemas que van de la idea al artículo. Un artículo escrito completamente por IA pasó la revisión de un taller de ICLR, aunque sus autores lo retiraron y reconocen citas inexactas. Kosmos acierta en cerca del 80 por ciento de sus afirmaciones; es decir, una de cada cinco está mal. Y en otro proyecto, un juez prefiere el artículo humano casi nueve de cada diez veces. Producir ya no es el cuello de botella. Juzgar, sí.</a:t>
             </a:r>
           </a:p>
         </p:txBody>
@@ -3570,7 +3570,7 @@
           <a:lstStyle/>
           <a:p>
             <a:r>
-              <a:t>Corre la demo, o muestra el corte grabado de 60 segundos. Señala los archivos de salida: plan.md, las notas de cada investigador, la verificación de cada cita y la evaluación del juez. El punto: el harness se escribe, no se programa.</a:t>
+              <a:t>Les muestro una versión pequeña de todo esto, hecha para exoesqueletos. Es un sistema de deep research en Claude Code, y no tiene código: son seis archivos de texto. Un líder que planea, investigadores que buscan, un verificador que abre cada fuente y un juez que califica con una rúbrica. Le pregunto qué controles de exoesqueletos de tobillo reducen el costo metabólico al caminar… El harness se escribe, no se programa. Está en el repositorio, para que lo usen.</a:t>
             </a:r>
           </a:p>
         </p:txBody>
@@ -3628,7 +3628,7 @@
           <a:lstStyle/>
           <a:p>
             <a:r>
-              <a:t>Esta diapositiva cierra la tesis: no basta con tener un juez, hay que saber qué tan bueno es. Los tres números responden la misma pregunta en dos estudios distintos, así que compáralos como orden de magnitud, no como una tabla exacta. 58%: Xu et al. (ACL 2023, tabla 4), 109 pares con respuesta de referencia; BERTScore da 57% y BLEURT 62%, apenas por encima del azar. 74% y 84%: ResearchQA (Li, Chang, Malaviya y Yatskar, TACL 2026), un juez LLM con rúbricas frente al acuerdo entre dos expertos. 11%: el mismo paper, sobre las rúbricas generadas por el modelo sin apoyarse en surveys; las que se basan en fuentes fallan menos. El encuadre viene de la clase 10 de Akari Asai, Deep Research Agents, CMU 11-768 (otoño 2026), que recomienda auditar la rúbrica antes de usarla. Llévalo a la práctica: antes de confiar en tu juez automático, califica tú tres reportes y compara con sus puntajes.</a:t>
+              <a:t>Última parte. Si todo depende del juez, hay que preguntar: ¿qué tan bueno es el juez? Una métrica automática de similitud coincide con los expertos el 58 por ciento de las veces, apenas por encima del azar. Un modelo de lenguaje usado como juez, con rúbricas, el 74. Y dos expertos entre sí, el 84: ese es el techo. Y las rúbricas también fallan. Antes de confiar en un juez automático, califiquen ustedes algunos casos y comparen.</a:t>
             </a:r>
           </a:p>
         </p:txBody>
@@ -3686,7 +3686,7 @@
           <a:lstStyle/>
           <a:p>
             <a:r>
-              <a:t>Vuelve a la diapositiva 2: cada falla es una falla del juez. Las citas inventadas son un ciclo sin juez: en el estudio de OpenScholar (Asai et al., Nature 2026), GPT-4o sin búsqueda inventó citas en el 78–90% de los casos al pedirle literatura reciente; el reward hacking es un juez que el agente aprendió a engañar; la fuga de datos es un juez que ya vio la respuesta; el prompt injection envenena lo que el agente observa. Los checks van de más barato a más caro: minutos para los tres primeros, horas para reimplementar; guarda eso para tus tablas principales. Un segundo modelo de la misma familia comparte los mismos puntos ciegos: usa uno de otro laboratorio. La frontera irregular (Dell'Acqua et al., 758 consultores de BCG): dentro de la frontera de la IA, 12.2% más tareas y 25.1% más rápido; fuera de ella, 19% menos probabilidad de acertar. Sin un juez propio no sabes de qué lado estás. Menciona la política de EAFIT sobre uso de IA y autoría, y la regla práctica de divulgación: decláralo donde aparezca tu nombre.</a:t>
+              <a:t>Todos estos ciclos fallan de la misma forma: con un juez débil o fácil de engañar. Sin juez, el modelo inventa citas. Con un juez débil, el agente aprende a engañarlo. Si el juez ya vio la respuesta, el resultado no vale. Y si alguien envenena lo que el agente lee, el agente obedece. Lo que ayuda: que otro agente ataque el resultado, que lo revise un modelo de otra empresa, y para lo que de verdad importa, reimplementarlo ustedes mismos.</a:t>
             </a:r>
           </a:p>
         </p:txBody>
@@ -3744,7 +3744,7 @@
           <a:lstStyle/>
           <a:p>
             <a:r>
-              <a:t>Haz una pausa en el titular antes de mostrar los tres niveles. Cada nivel le pasa más trabajo al agente y exige un juez más explícito: en el 1 juzgas tú cada respuesta; en el 2 tu criterio queda escrito en el skill; en el 3, en la métrica. Luego abre a preguntas.</a:t>
+              <a:t>Cierro con esto. El modelo corre el ciclo; ustedes deciden qué cuenta como mejor. ¿Qué pueden hacer el lunes? Tres niveles. Uno: escriban un archivo de instrucciones con su campo y sus reglas, y denle sus propios artículos. Dos: empaqueten en skills lo que repiten. Tres: monten ciclos autónomos solo donde tengan una métrica barata y honesta. Todo el material, las animaciones y la demo están en el repositorio. Muchas gracias.</a:t>
             </a:r>
           </a:p>
         </p:txBody>
@@ -3802,7 +3802,7 @@
           <a:lstStyle/>
           <a:p>
             <a:r>
-              <a:t>El modelo no devuelve una respuesta: devuelve una distribución sobre todo el vocabulario. Idea clave: no es una base de datos; si no le das la fuente, genera lo que un texto «probablemente diría». Las probabilidades son ilustrativas hasta correr datos_siguiente_token.py.</a:t>
+              <a:t>Y con esos tokens, ¿qué hace el modelo? Una sola cosa: predice el siguiente. Le doy «Durante la fase de apoyo de la marcha, la rodilla…» y me devuelve una probabilidad para cada token posible. Fíjense que no devuelve una respuesta: devuelve una distribución. Esto es importante para nosotros como investigadores: el modelo no es una base de datos. Si no le damos la fuente, escribe lo que un texto así probablemente diría, sea cierto o no.</a:t>
             </a:r>
           </a:p>
         </p:txBody>
@@ -3860,7 +3860,7 @@
           <a:lstStyle/>
           <a:p>
             <a:r>
-              <a:t>Generar es un ciclo: predecir, elegir, agregar, repetir. La temperatura controla cuánto se arriesga al elegir: baja, casi siempre el más probable (repetitivo pero estable); alta, tokens menos probables (más variado, más errores). Por eso la misma pregunta da respuestas distintas.</a:t>
+              <a:t>Para escribir un párrafo, el modelo repite ese paso. Predice, elige un token, lo agrega al texto y vuelve a predecir. Token por token. Y hay una perilla que se llama temperatura. Con temperatura baja casi siempre elige el más probable: respuestas estables pero repetitivas. Con temperatura alta se arriesga más: más variedad, pero más errores. Por eso, si le hacen la misma pregunta dos veces, pueden recibir dos respuestas distintas.</a:t>
             </a:r>
           </a:p>
         </p:txBody>
@@ -3918,7 +3918,7 @@
           <a:lstStyle/>
           <a:p>
             <a:r>
-              <a:t>Lo primero que hace el programa es cambiar cada número de token por una lista de miles de números: su embedding. Durante el entrenamiento, los tokens que aparecen en contextos parecidos terminan cerca. Este mapa es ilustrativo: los reales tienen miles de dimensiones. Vuelven en la Parte 2: así buscan los agentes.</a:t>
+              <a:t>Ahora, adentro del programa, cada token se convierte en una lista de números, un vector. Lo interesante es que, después del entrenamiento, los tokens con significado parecido quedan cerca: rodilla, cadera y tobillo quedan juntos; marcha y carrera, juntos; proteína y enzima, lejos de todo eso. Este mapa es una simplificación en dos dimensiones; los reales tienen miles. Guarden esta idea, porque vuelve más adelante: así es como buscan información los agentes.</a:t>
             </a:r>
           </a:p>
         </p:txBody>
@@ -3976,7 +3976,7 @@
           <a:lstStyle/>
           <a:p>
             <a:r>
-              <a:t>Aquí está el primer juez de la charla. En el entrenamiento se tapa la palabra siguiente de un texto real y se le pide al modelo que la prediga. La pérdida es menos el logaritmo de la probabilidad que le dio a la correcta: si le dio 5%, la pérdida es alta; si le dio 90%, casi cero. El texto mismo es el juez.</a:t>
+              <a:t>Ahora sí, ¿cómo aprende el modelo? Con un juez muy simple: el texto mismo. Tomamos una frase real, tapamos la palabra siguiente y le pedimos al modelo que la prediga. Aquí la palabra correcta era «flexiona», y el modelo le había dado apenas un cinco por ciento. Eso lo medimos con la pérdida: qué tan sorprendido quedó el modelo con la respuesta correcta. Después de ajustar los números, le da sesenta y dos por ciento, y la pérdida baja. Aprender es eso: equivocarse cada vez menos.</a:t>
             </a:r>
           </a:p>
         </p:txBody>

</xml_diff>